<commit_message>
Update NetOnNet.drawio to correct edge styles and adjust geometry positions
</commit_message>
<xml_diff>
--- a/Grupparbete Databasmodellering.pptx
+++ b/Grupparbete Databasmodellering.pptx
@@ -124,14 +124,6 @@
 </p:presentation>
 </file>
 
-<file path=ppt/revisionInfo.xml><?xml version="1.0" encoding="utf-8"?>
-<p1510:revInfo xmlns:a="http://schemas.openxmlformats.org/drawingml/2006/main" xmlns:r="http://schemas.openxmlformats.org/officeDocument/2006/relationships" xmlns:p1510="http://schemas.microsoft.com/office/powerpoint/2015/10/main">
-  <p1510:revLst>
-    <p1510:client id="{ED032E7B-360F-4A95-AB15-0770811AC57F}" v="60" dt="2026-03-12T13:14:24.640"/>
-  </p1510:revLst>
-</p1510:revInfo>
-</file>
-
 <file path=ppt/notesMasters/notesMaster1.xml><?xml version="1.0" encoding="utf-8"?>
 <p:notesMaster xmlns:a="http://schemas.openxmlformats.org/drawingml/2006/main" xmlns:r="http://schemas.openxmlformats.org/officeDocument/2006/relationships" xmlns:p="http://schemas.openxmlformats.org/presentationml/2006/main">
   <p:cSld>
@@ -890,8 +882,8 @@
               <a:t> </a:t>
             </a:r>
             <a:r>
-              <a:rPr lang="sv-SE"/>
-              <a:t>är kop</a:t>
+              <a:rPr lang="sv-SE" dirty="0"/>
+              <a:t>är kopplad</a:t>
             </a:r>
             <a:endParaRPr lang="en-SE" dirty="0"/>
           </a:p>
@@ -7408,7 +7400,7 @@
               <a:rPr lang="en-GB" dirty="0">
                 <a:hlinkClick r:id="rId6"/>
               </a:rPr>
-              <a:t>Star and Snowflake - v6 FINAL</a:t>
+              <a:t>Star and Snowflake (ERD)</a:t>
             </a:r>
             <a:r>
               <a:rPr lang="sv-SE" dirty="0">
@@ -8094,11 +8086,10 @@
               <a:t>ERD(</a:t>
             </a:r>
             <a:r>
-              <a:rPr lang="sv-SE" dirty="0" err="1">
-                <a:latin typeface="Segoe UI"/>
-                <a:cs typeface="Segoe UI"/>
+              <a:rPr lang="en-GB" dirty="0">
+                <a:hlinkClick r:id="rId6"/>
               </a:rPr>
-              <a:t>Snowflake</a:t>
+              <a:t>Star and Snowflake (ERD)</a:t>
             </a:r>
             <a:r>
               <a:rPr lang="sv-SE" dirty="0">

</xml_diff>